<commit_message>
Add permissions details to each stage of the deployment guide
Adds a new function to the script to dynamically generate and add permission boxes to each slide in the PowerPoint, detailing required roles and access for each stage of the Azure deployment flow.

Replit-Commit-Author: Agent
Replit-Commit-Session-Id: 6d2574e3-cf59-4195-8e61-d725d2127375
Replit-Commit-Checkpoint-Type: full_checkpoint
Replit-Commit-Event-Id: e6414448-48d1-4063-999f-67286a8869bb
Replit-Helium-Checkpoint-Created: true
</commit_message>
<xml_diff>
--- a/FridayReportAI_Azure_Deployment_Flow.pptx
+++ b/FridayReportAI_Azure_Deployment_Flow.pptx
@@ -2893,6 +2893,331 @@
           </a:p>
         </p:txBody>
       </p:sp>
+      <p:sp>
+        <p:nvSpPr>
+          <p:cNvPr id="27" name="Shape 25"/>
+          <p:cNvSpPr/>
+          <p:nvPr/>
+        </p:nvSpPr>
+        <p:spPr>
+          <a:xfrm>
+            <a:off x="548640" y="4389120"/>
+            <a:ext cx="5029200" cy="1225296"/>
+          </a:xfrm>
+          <a:prstGeom prst="rect">
+            <a:avLst>
+              <a:gd name="adj" fmla="val 4478"/>
+            </a:avLst>
+          </a:prstGeom>
+          <a:solidFill>
+            <a:srgbClr val="FAF5FF"/>
+          </a:solidFill>
+          <a:ln w="25400">
+            <a:solidFill>
+              <a:srgbClr val="9333EA"/>
+            </a:solidFill>
+            <a:prstDash val="solid"/>
+          </a:ln>
+        </p:spPr>
+      </p:sp>
+      <p:sp>
+        <p:nvSpPr>
+          <p:cNvPr id="28" name="Shape 26"/>
+          <p:cNvSpPr/>
+          <p:nvPr/>
+        </p:nvSpPr>
+        <p:spPr>
+          <a:xfrm>
+            <a:off x="548640" y="4389120"/>
+            <a:ext cx="5029200" cy="54864"/>
+          </a:xfrm>
+          <a:prstGeom prst="rect">
+            <a:avLst/>
+          </a:prstGeom>
+          <a:solidFill>
+            <a:srgbClr val="9333EA"/>
+          </a:solidFill>
+          <a:ln/>
+        </p:spPr>
+      </p:sp>
+      <p:sp>
+        <p:nvSpPr>
+          <p:cNvPr id="29" name="Text 27"/>
+          <p:cNvSpPr/>
+          <p:nvPr/>
+        </p:nvSpPr>
+        <p:spPr>
+          <a:xfrm>
+            <a:off x="658368" y="4462272"/>
+            <a:ext cx="4809744" cy="1078992"/>
+          </a:xfrm>
+          <a:prstGeom prst="rect">
+            <a:avLst/>
+          </a:prstGeom>
+          <a:noFill/>
+          <a:ln/>
+        </p:spPr>
+        <p:txBody>
+          <a:bodyPr wrap="square" rtlCol="0" anchor="t"/>
+          <a:lstStyle/>
+          <a:p>
+            <a:pPr indent="0" marL="0">
+              <a:buNone/>
+            </a:pPr>
+            <a:r>
+              <a:rPr lang="en-US" sz="900" b="1" dirty="0">
+                <a:solidFill>
+                  <a:srgbClr val="9333EA"/>
+                </a:solidFill>
+                <a:latin typeface="Segoe UI" pitchFamily="34" charset="0"/>
+                <a:ea typeface="Segoe UI" pitchFamily="34" charset="-122"/>
+                <a:cs typeface="Segoe UI" pitchFamily="34" charset="-120"/>
+              </a:rPr>
+              <a:t>🔒 PERMISSIONS REQUIRED</a:t>
+            </a:r>
+            <a:endParaRPr lang="en-US" sz="900" dirty="0"/>
+          </a:p>
+          <a:p>
+            <a:pPr indent="0" marL="0">
+              <a:buNone/>
+            </a:pPr>
+            <a:r>
+              <a:rPr lang="en-US" sz="900" b="1" dirty="0">
+                <a:solidFill>
+                  <a:srgbClr val="17255A"/>
+                </a:solidFill>
+                <a:latin typeface="Segoe UI" pitchFamily="34" charset="0"/>
+                <a:ea typeface="Segoe UI" pitchFamily="34" charset="-122"/>
+                <a:cs typeface="Segoe UI" pitchFamily="34" charset="-120"/>
+              </a:rPr>
+              <a:t>Role: Developer / CI Pipeline</a:t>
+            </a:r>
+            <a:endParaRPr lang="en-US" sz="900" dirty="0"/>
+          </a:p>
+          <a:p>
+            <a:pPr indent="0" marL="0">
+              <a:buNone/>
+            </a:pPr>
+            <a:r>
+              <a:rPr lang="en-US" sz="900" dirty="0">
+                <a:solidFill>
+                  <a:srgbClr val="17255A"/>
+                </a:solidFill>
+                <a:latin typeface="Segoe UI" pitchFamily="34" charset="0"/>
+                <a:ea typeface="Segoe UI" pitchFamily="34" charset="-122"/>
+                <a:cs typeface="Segoe UI" pitchFamily="34" charset="-120"/>
+              </a:rPr>
+              <a:t>• Read access to source code repository</a:t>
+            </a:r>
+            <a:endParaRPr lang="en-US" sz="900" dirty="0"/>
+          </a:p>
+          <a:p>
+            <a:pPr indent="0" marL="0">
+              <a:buNone/>
+            </a:pPr>
+            <a:r>
+              <a:rPr lang="en-US" sz="900" dirty="0">
+                <a:solidFill>
+                  <a:srgbClr val="17255A"/>
+                </a:solidFill>
+                <a:latin typeface="Segoe UI" pitchFamily="34" charset="0"/>
+                <a:ea typeface="Segoe UI" pitchFamily="34" charset="-122"/>
+                <a:cs typeface="Segoe UI" pitchFamily="34" charset="-120"/>
+              </a:rPr>
+              <a:t>• Docker daemon access (local or CI runner)</a:t>
+            </a:r>
+            <a:endParaRPr lang="en-US" sz="900" dirty="0"/>
+          </a:p>
+          <a:p>
+            <a:pPr indent="0" marL="0">
+              <a:buNone/>
+            </a:pPr>
+            <a:r>
+              <a:rPr lang="en-US" sz="900" dirty="0">
+                <a:solidFill>
+                  <a:srgbClr val="17255A"/>
+                </a:solidFill>
+                <a:latin typeface="Segoe UI" pitchFamily="34" charset="0"/>
+                <a:ea typeface="Segoe UI" pitchFamily="34" charset="-122"/>
+                <a:cs typeface="Segoe UI" pitchFamily="34" charset="-120"/>
+              </a:rPr>
+              <a:t>• npm registry access for package installation</a:t>
+            </a:r>
+            <a:endParaRPr lang="en-US" sz="900" dirty="0"/>
+          </a:p>
+          <a:p>
+            <a:pPr indent="0" marL="0">
+              <a:buNone/>
+            </a:pPr>
+            <a:r>
+              <a:rPr lang="en-US" sz="900" dirty="0">
+                <a:solidFill>
+                  <a:srgbClr val="17255A"/>
+                </a:solidFill>
+                <a:latin typeface="Segoe UI" pitchFamily="34" charset="0"/>
+                <a:ea typeface="Segoe UI" pitchFamily="34" charset="-122"/>
+                <a:cs typeface="Segoe UI" pitchFamily="34" charset="-120"/>
+              </a:rPr>
+              <a:t>• No Azure permissions needed at this stage</a:t>
+            </a:r>
+            <a:endParaRPr lang="en-US" sz="900" dirty="0"/>
+          </a:p>
+        </p:txBody>
+      </p:sp>
+      <p:sp>
+        <p:nvSpPr>
+          <p:cNvPr id="30" name="Shape 28"/>
+          <p:cNvSpPr/>
+          <p:nvPr/>
+        </p:nvSpPr>
+        <p:spPr>
+          <a:xfrm>
+            <a:off x="5943600" y="4389120"/>
+            <a:ext cx="5669280" cy="1024128"/>
+          </a:xfrm>
+          <a:prstGeom prst="rect">
+            <a:avLst>
+              <a:gd name="adj" fmla="val 5357"/>
+            </a:avLst>
+          </a:prstGeom>
+          <a:solidFill>
+            <a:srgbClr val="FAF5FF"/>
+          </a:solidFill>
+          <a:ln w="25400">
+            <a:solidFill>
+              <a:srgbClr val="9333EA"/>
+            </a:solidFill>
+            <a:prstDash val="solid"/>
+          </a:ln>
+        </p:spPr>
+      </p:sp>
+      <p:sp>
+        <p:nvSpPr>
+          <p:cNvPr id="31" name="Shape 29"/>
+          <p:cNvSpPr/>
+          <p:nvPr/>
+        </p:nvSpPr>
+        <p:spPr>
+          <a:xfrm>
+            <a:off x="5943600" y="4389120"/>
+            <a:ext cx="5669280" cy="54864"/>
+          </a:xfrm>
+          <a:prstGeom prst="rect">
+            <a:avLst/>
+          </a:prstGeom>
+          <a:solidFill>
+            <a:srgbClr val="9333EA"/>
+          </a:solidFill>
+          <a:ln/>
+        </p:spPr>
+      </p:sp>
+      <p:sp>
+        <p:nvSpPr>
+          <p:cNvPr id="32" name="Text 30"/>
+          <p:cNvSpPr/>
+          <p:nvPr/>
+        </p:nvSpPr>
+        <p:spPr>
+          <a:xfrm>
+            <a:off x="6053328" y="4462272"/>
+            <a:ext cx="5449824" cy="877824"/>
+          </a:xfrm>
+          <a:prstGeom prst="rect">
+            <a:avLst/>
+          </a:prstGeom>
+          <a:noFill/>
+          <a:ln/>
+        </p:spPr>
+        <p:txBody>
+          <a:bodyPr wrap="square" rtlCol="0" anchor="t"/>
+          <a:lstStyle/>
+          <a:p>
+            <a:pPr indent="0" marL="0">
+              <a:buNone/>
+            </a:pPr>
+            <a:r>
+              <a:rPr lang="en-US" sz="900" b="1" dirty="0">
+                <a:solidFill>
+                  <a:srgbClr val="9333EA"/>
+                </a:solidFill>
+                <a:latin typeface="Segoe UI" pitchFamily="34" charset="0"/>
+                <a:ea typeface="Segoe UI" pitchFamily="34" charset="-122"/>
+                <a:cs typeface="Segoe UI" pitchFamily="34" charset="-120"/>
+              </a:rPr>
+              <a:t>🔒 PERMISSIONS REQUIRED</a:t>
+            </a:r>
+            <a:endParaRPr lang="en-US" sz="900" dirty="0"/>
+          </a:p>
+          <a:p>
+            <a:pPr indent="0" marL="0">
+              <a:buNone/>
+            </a:pPr>
+            <a:r>
+              <a:rPr lang="en-US" sz="900" b="1" dirty="0">
+                <a:solidFill>
+                  <a:srgbClr val="17255A"/>
+                </a:solidFill>
+                <a:latin typeface="Segoe UI" pitchFamily="34" charset="0"/>
+                <a:ea typeface="Segoe UI" pitchFamily="34" charset="-122"/>
+                <a:cs typeface="Segoe UI" pitchFamily="34" charset="-120"/>
+              </a:rPr>
+              <a:t>Role: CI/CD Service Principal (if automated)</a:t>
+            </a:r>
+            <a:endParaRPr lang="en-US" sz="900" dirty="0"/>
+          </a:p>
+          <a:p>
+            <a:pPr indent="0" marL="0">
+              <a:buNone/>
+            </a:pPr>
+            <a:r>
+              <a:rPr lang="en-US" sz="900" dirty="0">
+                <a:solidFill>
+                  <a:srgbClr val="17255A"/>
+                </a:solidFill>
+                <a:latin typeface="Segoe UI" pitchFamily="34" charset="0"/>
+                <a:ea typeface="Segoe UI" pitchFamily="34" charset="-122"/>
+                <a:cs typeface="Segoe UI" pitchFamily="34" charset="-120"/>
+              </a:rPr>
+              <a:t>• Azure DevOps: Build Agent access</a:t>
+            </a:r>
+            <a:endParaRPr lang="en-US" sz="900" dirty="0"/>
+          </a:p>
+          <a:p>
+            <a:pPr indent="0" marL="0">
+              <a:buNone/>
+            </a:pPr>
+            <a:r>
+              <a:rPr lang="en-US" sz="900" dirty="0">
+                <a:solidFill>
+                  <a:srgbClr val="17255A"/>
+                </a:solidFill>
+                <a:latin typeface="Segoe UI" pitchFamily="34" charset="0"/>
+                <a:ea typeface="Segoe UI" pitchFamily="34" charset="-122"/>
+                <a:cs typeface="Segoe UI" pitchFamily="34" charset="-120"/>
+              </a:rPr>
+              <a:t>• GitHub Actions: GITHUB_TOKEN (for checkout)</a:t>
+            </a:r>
+            <a:endParaRPr lang="en-US" sz="900" dirty="0"/>
+          </a:p>
+          <a:p>
+            <a:pPr indent="0" marL="0">
+              <a:buNone/>
+            </a:pPr>
+            <a:r>
+              <a:rPr lang="en-US" sz="900" dirty="0">
+                <a:solidFill>
+                  <a:srgbClr val="17255A"/>
+                </a:solidFill>
+                <a:latin typeface="Segoe UI" pitchFamily="34" charset="0"/>
+                <a:ea typeface="Segoe UI" pitchFamily="34" charset="-122"/>
+                <a:cs typeface="Segoe UI" pitchFamily="34" charset="-120"/>
+              </a:rPr>
+              <a:t>• Docker socket or Docker-in-Docker capability</a:t>
+            </a:r>
+            <a:endParaRPr lang="en-US" sz="900" dirty="0"/>
+          </a:p>
+        </p:txBody>
+      </p:sp>
     </p:spTree>
   </p:cSld>
   <p:clrMapOvr>
@@ -3889,6 +4214,331 @@
           </a:p>
         </p:txBody>
       </p:sp>
+      <p:sp>
+        <p:nvSpPr>
+          <p:cNvPr id="25" name="Shape 23"/>
+          <p:cNvSpPr/>
+          <p:nvPr/>
+        </p:nvSpPr>
+        <p:spPr>
+          <a:xfrm>
+            <a:off x="548640" y="4572000"/>
+            <a:ext cx="5029200" cy="1225296"/>
+          </a:xfrm>
+          <a:prstGeom prst="rect">
+            <a:avLst>
+              <a:gd name="adj" fmla="val 4478"/>
+            </a:avLst>
+          </a:prstGeom>
+          <a:solidFill>
+            <a:srgbClr val="FAF5FF"/>
+          </a:solidFill>
+          <a:ln w="25400">
+            <a:solidFill>
+              <a:srgbClr val="9333EA"/>
+            </a:solidFill>
+            <a:prstDash val="solid"/>
+          </a:ln>
+        </p:spPr>
+      </p:sp>
+      <p:sp>
+        <p:nvSpPr>
+          <p:cNvPr id="26" name="Shape 24"/>
+          <p:cNvSpPr/>
+          <p:nvPr/>
+        </p:nvSpPr>
+        <p:spPr>
+          <a:xfrm>
+            <a:off x="548640" y="4572000"/>
+            <a:ext cx="5029200" cy="54864"/>
+          </a:xfrm>
+          <a:prstGeom prst="rect">
+            <a:avLst/>
+          </a:prstGeom>
+          <a:solidFill>
+            <a:srgbClr val="9333EA"/>
+          </a:solidFill>
+          <a:ln/>
+        </p:spPr>
+      </p:sp>
+      <p:sp>
+        <p:nvSpPr>
+          <p:cNvPr id="27" name="Text 25"/>
+          <p:cNvSpPr/>
+          <p:nvPr/>
+        </p:nvSpPr>
+        <p:spPr>
+          <a:xfrm>
+            <a:off x="658368" y="4645152"/>
+            <a:ext cx="4809744" cy="1078992"/>
+          </a:xfrm>
+          <a:prstGeom prst="rect">
+            <a:avLst/>
+          </a:prstGeom>
+          <a:noFill/>
+          <a:ln/>
+        </p:spPr>
+        <p:txBody>
+          <a:bodyPr wrap="square" rtlCol="0" anchor="t"/>
+          <a:lstStyle/>
+          <a:p>
+            <a:pPr indent="0" marL="0">
+              <a:buNone/>
+            </a:pPr>
+            <a:r>
+              <a:rPr lang="en-US" sz="900" b="1" dirty="0">
+                <a:solidFill>
+                  <a:srgbClr val="9333EA"/>
+                </a:solidFill>
+                <a:latin typeface="Segoe UI" pitchFamily="34" charset="0"/>
+                <a:ea typeface="Segoe UI" pitchFamily="34" charset="-122"/>
+                <a:cs typeface="Segoe UI" pitchFamily="34" charset="-120"/>
+              </a:rPr>
+              <a:t>🔒 PERMISSIONS REQUIRED</a:t>
+            </a:r>
+            <a:endParaRPr lang="en-US" sz="900" dirty="0"/>
+          </a:p>
+          <a:p>
+            <a:pPr indent="0" marL="0">
+              <a:buNone/>
+            </a:pPr>
+            <a:r>
+              <a:rPr lang="en-US" sz="900" b="1" dirty="0">
+                <a:solidFill>
+                  <a:srgbClr val="17255A"/>
+                </a:solidFill>
+                <a:latin typeface="Segoe UI" pitchFamily="34" charset="0"/>
+                <a:ea typeface="Segoe UI" pitchFamily="34" charset="-122"/>
+                <a:cs typeface="Segoe UI" pitchFamily="34" charset="-120"/>
+              </a:rPr>
+              <a:t>Role: Deployer / CI Service Principal</a:t>
+            </a:r>
+            <a:endParaRPr lang="en-US" sz="900" dirty="0"/>
+          </a:p>
+          <a:p>
+            <a:pPr indent="0" marL="0">
+              <a:buNone/>
+            </a:pPr>
+            <a:r>
+              <a:rPr lang="en-US" sz="900" dirty="0">
+                <a:solidFill>
+                  <a:srgbClr val="17255A"/>
+                </a:solidFill>
+                <a:latin typeface="Segoe UI" pitchFamily="34" charset="0"/>
+                <a:ea typeface="Segoe UI" pitchFamily="34" charset="-122"/>
+                <a:cs typeface="Segoe UI" pitchFamily="34" charset="-120"/>
+              </a:rPr>
+              <a:t>• AcrPush — Push images to Container Registry</a:t>
+            </a:r>
+            <a:endParaRPr lang="en-US" sz="900" dirty="0"/>
+          </a:p>
+          <a:p>
+            <a:pPr indent="0" marL="0">
+              <a:buNone/>
+            </a:pPr>
+            <a:r>
+              <a:rPr lang="en-US" sz="900" dirty="0">
+                <a:solidFill>
+                  <a:srgbClr val="17255A"/>
+                </a:solidFill>
+                <a:latin typeface="Segoe UI" pitchFamily="34" charset="0"/>
+                <a:ea typeface="Segoe UI" pitchFamily="34" charset="-122"/>
+                <a:cs typeface="Segoe UI" pitchFamily="34" charset="-120"/>
+              </a:rPr>
+              <a:t>• AcrPull — Pull images (assigned to Container App identity)</a:t>
+            </a:r>
+            <a:endParaRPr lang="en-US" sz="900" dirty="0"/>
+          </a:p>
+          <a:p>
+            <a:pPr indent="0" marL="0">
+              <a:buNone/>
+            </a:pPr>
+            <a:r>
+              <a:rPr lang="en-US" sz="900" dirty="0">
+                <a:solidFill>
+                  <a:srgbClr val="17255A"/>
+                </a:solidFill>
+                <a:latin typeface="Segoe UI" pitchFamily="34" charset="0"/>
+                <a:ea typeface="Segoe UI" pitchFamily="34" charset="-122"/>
+                <a:cs typeface="Segoe UI" pitchFamily="34" charset="-120"/>
+              </a:rPr>
+              <a:t>• az acr login — Requires AAD authentication</a:t>
+            </a:r>
+            <a:endParaRPr lang="en-US" sz="900" dirty="0"/>
+          </a:p>
+          <a:p>
+            <a:pPr indent="0" marL="0">
+              <a:buNone/>
+            </a:pPr>
+            <a:r>
+              <a:rPr lang="en-US" sz="900" dirty="0">
+                <a:solidFill>
+                  <a:srgbClr val="17255A"/>
+                </a:solidFill>
+                <a:latin typeface="Segoe UI" pitchFamily="34" charset="0"/>
+                <a:ea typeface="Segoe UI" pitchFamily="34" charset="-122"/>
+                <a:cs typeface="Segoe UI" pitchFamily="34" charset="-120"/>
+              </a:rPr>
+              <a:t>• If using az acr build: AcrPush + Contributor on ACR</a:t>
+            </a:r>
+            <a:endParaRPr lang="en-US" sz="900" dirty="0"/>
+          </a:p>
+        </p:txBody>
+      </p:sp>
+      <p:sp>
+        <p:nvSpPr>
+          <p:cNvPr id="28" name="Shape 26"/>
+          <p:cNvSpPr/>
+          <p:nvPr/>
+        </p:nvSpPr>
+        <p:spPr>
+          <a:xfrm>
+            <a:off x="5943600" y="4572000"/>
+            <a:ext cx="5669280" cy="1024128"/>
+          </a:xfrm>
+          <a:prstGeom prst="rect">
+            <a:avLst>
+              <a:gd name="adj" fmla="val 5357"/>
+            </a:avLst>
+          </a:prstGeom>
+          <a:solidFill>
+            <a:srgbClr val="FAF5FF"/>
+          </a:solidFill>
+          <a:ln w="25400">
+            <a:solidFill>
+              <a:srgbClr val="9333EA"/>
+            </a:solidFill>
+            <a:prstDash val="solid"/>
+          </a:ln>
+        </p:spPr>
+      </p:sp>
+      <p:sp>
+        <p:nvSpPr>
+          <p:cNvPr id="29" name="Shape 27"/>
+          <p:cNvSpPr/>
+          <p:nvPr/>
+        </p:nvSpPr>
+        <p:spPr>
+          <a:xfrm>
+            <a:off x="5943600" y="4572000"/>
+            <a:ext cx="5669280" cy="54864"/>
+          </a:xfrm>
+          <a:prstGeom prst="rect">
+            <a:avLst/>
+          </a:prstGeom>
+          <a:solidFill>
+            <a:srgbClr val="9333EA"/>
+          </a:solidFill>
+          <a:ln/>
+        </p:spPr>
+      </p:sp>
+      <p:sp>
+        <p:nvSpPr>
+          <p:cNvPr id="30" name="Text 28"/>
+          <p:cNvSpPr/>
+          <p:nvPr/>
+        </p:nvSpPr>
+        <p:spPr>
+          <a:xfrm>
+            <a:off x="6053328" y="4645152"/>
+            <a:ext cx="5449824" cy="877824"/>
+          </a:xfrm>
+          <a:prstGeom prst="rect">
+            <a:avLst/>
+          </a:prstGeom>
+          <a:noFill/>
+          <a:ln/>
+        </p:spPr>
+        <p:txBody>
+          <a:bodyPr wrap="square" rtlCol="0" anchor="t"/>
+          <a:lstStyle/>
+          <a:p>
+            <a:pPr indent="0" marL="0">
+              <a:buNone/>
+            </a:pPr>
+            <a:r>
+              <a:rPr lang="en-US" sz="900" b="1" dirty="0">
+                <a:solidFill>
+                  <a:srgbClr val="9333EA"/>
+                </a:solidFill>
+                <a:latin typeface="Segoe UI" pitchFamily="34" charset="0"/>
+                <a:ea typeface="Segoe UI" pitchFamily="34" charset="-122"/>
+                <a:cs typeface="Segoe UI" pitchFamily="34" charset="-120"/>
+              </a:rPr>
+              <a:t>🔒 PERMISSIONS REQUIRED</a:t>
+            </a:r>
+            <a:endParaRPr lang="en-US" sz="900" dirty="0"/>
+          </a:p>
+          <a:p>
+            <a:pPr indent="0" marL="0">
+              <a:buNone/>
+            </a:pPr>
+            <a:r>
+              <a:rPr lang="en-US" sz="900" b="1" dirty="0">
+                <a:solidFill>
+                  <a:srgbClr val="17255A"/>
+                </a:solidFill>
+                <a:latin typeface="Segoe UI" pitchFamily="34" charset="0"/>
+                <a:ea typeface="Segoe UI" pitchFamily="34" charset="-122"/>
+                <a:cs typeface="Segoe UI" pitchFamily="34" charset="-120"/>
+              </a:rPr>
+              <a:t>Role: ACR Admin (initial setup only)</a:t>
+            </a:r>
+            <a:endParaRPr lang="en-US" sz="900" dirty="0"/>
+          </a:p>
+          <a:p>
+            <a:pPr indent="0" marL="0">
+              <a:buNone/>
+            </a:pPr>
+            <a:r>
+              <a:rPr lang="en-US" sz="900" dirty="0">
+                <a:solidFill>
+                  <a:srgbClr val="17255A"/>
+                </a:solidFill>
+                <a:latin typeface="Segoe UI" pitchFamily="34" charset="0"/>
+                <a:ea typeface="Segoe UI" pitchFamily="34" charset="-122"/>
+                <a:cs typeface="Segoe UI" pitchFamily="34" charset="-120"/>
+              </a:rPr>
+              <a:t>• Contributor on ACR resource (to create/configure)</a:t>
+            </a:r>
+            <a:endParaRPr lang="en-US" sz="900" dirty="0"/>
+          </a:p>
+          <a:p>
+            <a:pPr indent="0" marL="0">
+              <a:buNone/>
+            </a:pPr>
+            <a:r>
+              <a:rPr lang="en-US" sz="900" dirty="0">
+                <a:solidFill>
+                  <a:srgbClr val="17255A"/>
+                </a:solidFill>
+                <a:latin typeface="Segoe UI" pitchFamily="34" charset="0"/>
+                <a:ea typeface="Segoe UI" pitchFamily="34" charset="-122"/>
+                <a:cs typeface="Segoe UI" pitchFamily="34" charset="-120"/>
+              </a:rPr>
+              <a:t>• User Access Administrator (to assign AcrPush/AcrPull roles)</a:t>
+            </a:r>
+            <a:endParaRPr lang="en-US" sz="900" dirty="0"/>
+          </a:p>
+          <a:p>
+            <a:pPr indent="0" marL="0">
+              <a:buNone/>
+            </a:pPr>
+            <a:r>
+              <a:rPr lang="en-US" sz="900" dirty="0">
+                <a:solidFill>
+                  <a:srgbClr val="17255A"/>
+                </a:solidFill>
+                <a:latin typeface="Segoe UI" pitchFamily="34" charset="0"/>
+                <a:ea typeface="Segoe UI" pitchFamily="34" charset="-122"/>
+                <a:cs typeface="Segoe UI" pitchFamily="34" charset="-120"/>
+              </a:rPr>
+              <a:t>• Disable admin user — use RBAC-only access</a:t>
+            </a:r>
+            <a:endParaRPr lang="en-US" sz="900" dirty="0"/>
+          </a:p>
+        </p:txBody>
+      </p:sp>
     </p:spTree>
   </p:cSld>
   <p:clrMapOvr>
@@ -5063,6 +5713,399 @@
           </a:p>
         </p:txBody>
       </p:sp>
+      <p:sp>
+        <p:nvSpPr>
+          <p:cNvPr id="29" name="Shape 27"/>
+          <p:cNvSpPr/>
+          <p:nvPr/>
+        </p:nvSpPr>
+        <p:spPr>
+          <a:xfrm>
+            <a:off x="548640" y="4389120"/>
+            <a:ext cx="5029200" cy="1627632"/>
+          </a:xfrm>
+          <a:prstGeom prst="rect">
+            <a:avLst>
+              <a:gd name="adj" fmla="val 3371"/>
+            </a:avLst>
+          </a:prstGeom>
+          <a:solidFill>
+            <a:srgbClr val="FAF5FF"/>
+          </a:solidFill>
+          <a:ln w="25400">
+            <a:solidFill>
+              <a:srgbClr val="9333EA"/>
+            </a:solidFill>
+            <a:prstDash val="solid"/>
+          </a:ln>
+        </p:spPr>
+      </p:sp>
+      <p:sp>
+        <p:nvSpPr>
+          <p:cNvPr id="30" name="Shape 28"/>
+          <p:cNvSpPr/>
+          <p:nvPr/>
+        </p:nvSpPr>
+        <p:spPr>
+          <a:xfrm>
+            <a:off x="548640" y="4389120"/>
+            <a:ext cx="5029200" cy="54864"/>
+          </a:xfrm>
+          <a:prstGeom prst="rect">
+            <a:avLst/>
+          </a:prstGeom>
+          <a:solidFill>
+            <a:srgbClr val="9333EA"/>
+          </a:solidFill>
+          <a:ln/>
+        </p:spPr>
+      </p:sp>
+      <p:sp>
+        <p:nvSpPr>
+          <p:cNvPr id="31" name="Text 29"/>
+          <p:cNvSpPr/>
+          <p:nvPr/>
+        </p:nvSpPr>
+        <p:spPr>
+          <a:xfrm>
+            <a:off x="658368" y="4462272"/>
+            <a:ext cx="4809744" cy="1481328"/>
+          </a:xfrm>
+          <a:prstGeom prst="rect">
+            <a:avLst/>
+          </a:prstGeom>
+          <a:noFill/>
+          <a:ln/>
+        </p:spPr>
+        <p:txBody>
+          <a:bodyPr wrap="square" rtlCol="0" anchor="t"/>
+          <a:lstStyle/>
+          <a:p>
+            <a:pPr indent="0" marL="0">
+              <a:buNone/>
+            </a:pPr>
+            <a:r>
+              <a:rPr lang="en-US" sz="900" b="1" dirty="0">
+                <a:solidFill>
+                  <a:srgbClr val="9333EA"/>
+                </a:solidFill>
+                <a:latin typeface="Segoe UI" pitchFamily="34" charset="0"/>
+                <a:ea typeface="Segoe UI" pitchFamily="34" charset="-122"/>
+                <a:cs typeface="Segoe UI" pitchFamily="34" charset="-120"/>
+              </a:rPr>
+              <a:t>🔒 PERMISSIONS REQUIRED</a:t>
+            </a:r>
+            <a:endParaRPr lang="en-US" sz="900" dirty="0"/>
+          </a:p>
+          <a:p>
+            <a:pPr indent="0" marL="0">
+              <a:buNone/>
+            </a:pPr>
+            <a:r>
+              <a:rPr lang="en-US" sz="900" b="1" dirty="0">
+                <a:solidFill>
+                  <a:srgbClr val="17255A"/>
+                </a:solidFill>
+                <a:latin typeface="Segoe UI" pitchFamily="34" charset="0"/>
+                <a:ea typeface="Segoe UI" pitchFamily="34" charset="-122"/>
+                <a:cs typeface="Segoe UI" pitchFamily="34" charset="-120"/>
+              </a:rPr>
+              <a:t>Role: Infrastructure Admin / Terraform SP</a:t>
+            </a:r>
+            <a:endParaRPr lang="en-US" sz="900" dirty="0"/>
+          </a:p>
+          <a:p>
+            <a:pPr indent="0" marL="0">
+              <a:buNone/>
+            </a:pPr>
+            <a:r>
+              <a:rPr lang="en-US" sz="900" dirty="0">
+                <a:solidFill>
+                  <a:srgbClr val="17255A"/>
+                </a:solidFill>
+                <a:latin typeface="Segoe UI" pitchFamily="34" charset="0"/>
+                <a:ea typeface="Segoe UI" pitchFamily="34" charset="-122"/>
+                <a:cs typeface="Segoe UI" pitchFamily="34" charset="-120"/>
+              </a:rPr>
+              <a:t>• Contributor on Resource Group (create all resources)</a:t>
+            </a:r>
+            <a:endParaRPr lang="en-US" sz="900" dirty="0"/>
+          </a:p>
+          <a:p>
+            <a:pPr indent="0" marL="0">
+              <a:buNone/>
+            </a:pPr>
+            <a:r>
+              <a:rPr lang="en-US" sz="900" dirty="0">
+                <a:solidFill>
+                  <a:srgbClr val="17255A"/>
+                </a:solidFill>
+                <a:latin typeface="Segoe UI" pitchFamily="34" charset="0"/>
+                <a:ea typeface="Segoe UI" pitchFamily="34" charset="-122"/>
+                <a:cs typeface="Segoe UI" pitchFamily="34" charset="-120"/>
+              </a:rPr>
+              <a:t>• Microsoft.DBforPostgreSQL/* — Create PostgreSQL server</a:t>
+            </a:r>
+            <a:endParaRPr lang="en-US" sz="900" dirty="0"/>
+          </a:p>
+          <a:p>
+            <a:pPr indent="0" marL="0">
+              <a:buNone/>
+            </a:pPr>
+            <a:r>
+              <a:rPr lang="en-US" sz="900" dirty="0">
+                <a:solidFill>
+                  <a:srgbClr val="17255A"/>
+                </a:solidFill>
+                <a:latin typeface="Segoe UI" pitchFamily="34" charset="0"/>
+                <a:ea typeface="Segoe UI" pitchFamily="34" charset="-122"/>
+                <a:cs typeface="Segoe UI" pitchFamily="34" charset="-120"/>
+              </a:rPr>
+              <a:t>• Microsoft.Storage/* — Create Storage Account</a:t>
+            </a:r>
+            <a:endParaRPr lang="en-US" sz="900" dirty="0"/>
+          </a:p>
+          <a:p>
+            <a:pPr indent="0" marL="0">
+              <a:buNone/>
+            </a:pPr>
+            <a:r>
+              <a:rPr lang="en-US" sz="900" dirty="0">
+                <a:solidFill>
+                  <a:srgbClr val="17255A"/>
+                </a:solidFill>
+                <a:latin typeface="Segoe UI" pitchFamily="34" charset="0"/>
+                <a:ea typeface="Segoe UI" pitchFamily="34" charset="-122"/>
+                <a:cs typeface="Segoe UI" pitchFamily="34" charset="-120"/>
+              </a:rPr>
+              <a:t>• Microsoft.KeyVault/* — Create and configure Key Vault</a:t>
+            </a:r>
+            <a:endParaRPr lang="en-US" sz="900" dirty="0"/>
+          </a:p>
+          <a:p>
+            <a:pPr indent="0" marL="0">
+              <a:buNone/>
+            </a:pPr>
+            <a:r>
+              <a:rPr lang="en-US" sz="900" dirty="0">
+                <a:solidFill>
+                  <a:srgbClr val="17255A"/>
+                </a:solidFill>
+                <a:latin typeface="Segoe UI" pitchFamily="34" charset="0"/>
+                <a:ea typeface="Segoe UI" pitchFamily="34" charset="-122"/>
+                <a:cs typeface="Segoe UI" pitchFamily="34" charset="-120"/>
+              </a:rPr>
+              <a:t>• Microsoft.OperationalInsights/* — Create Log Analytics</a:t>
+            </a:r>
+            <a:endParaRPr lang="en-US" sz="900" dirty="0"/>
+          </a:p>
+          <a:p>
+            <a:pPr indent="0" marL="0">
+              <a:buNone/>
+            </a:pPr>
+            <a:r>
+              <a:rPr lang="en-US" sz="900" dirty="0">
+                <a:solidFill>
+                  <a:srgbClr val="17255A"/>
+                </a:solidFill>
+                <a:latin typeface="Segoe UI" pitchFamily="34" charset="0"/>
+                <a:ea typeface="Segoe UI" pitchFamily="34" charset="-122"/>
+                <a:cs typeface="Segoe UI" pitchFamily="34" charset="-120"/>
+              </a:rPr>
+              <a:t>• Microsoft.App/* — Create Container App Environment</a:t>
+            </a:r>
+            <a:endParaRPr lang="en-US" sz="900" dirty="0"/>
+          </a:p>
+        </p:txBody>
+      </p:sp>
+      <p:sp>
+        <p:nvSpPr>
+          <p:cNvPr id="32" name="Shape 30"/>
+          <p:cNvSpPr/>
+          <p:nvPr/>
+        </p:nvSpPr>
+        <p:spPr>
+          <a:xfrm>
+            <a:off x="5943600" y="4389120"/>
+            <a:ext cx="5669280" cy="1426464"/>
+          </a:xfrm>
+          <a:prstGeom prst="rect">
+            <a:avLst>
+              <a:gd name="adj" fmla="val 3846"/>
+            </a:avLst>
+          </a:prstGeom>
+          <a:solidFill>
+            <a:srgbClr val="FAF5FF"/>
+          </a:solidFill>
+          <a:ln w="25400">
+            <a:solidFill>
+              <a:srgbClr val="9333EA"/>
+            </a:solidFill>
+            <a:prstDash val="solid"/>
+          </a:ln>
+        </p:spPr>
+      </p:sp>
+      <p:sp>
+        <p:nvSpPr>
+          <p:cNvPr id="33" name="Shape 31"/>
+          <p:cNvSpPr/>
+          <p:nvPr/>
+        </p:nvSpPr>
+        <p:spPr>
+          <a:xfrm>
+            <a:off x="5943600" y="4389120"/>
+            <a:ext cx="5669280" cy="54864"/>
+          </a:xfrm>
+          <a:prstGeom prst="rect">
+            <a:avLst/>
+          </a:prstGeom>
+          <a:solidFill>
+            <a:srgbClr val="9333EA"/>
+          </a:solidFill>
+          <a:ln/>
+        </p:spPr>
+      </p:sp>
+      <p:sp>
+        <p:nvSpPr>
+          <p:cNvPr id="34" name="Text 32"/>
+          <p:cNvSpPr/>
+          <p:nvPr/>
+        </p:nvSpPr>
+        <p:spPr>
+          <a:xfrm>
+            <a:off x="6053328" y="4462272"/>
+            <a:ext cx="5449824" cy="1280160"/>
+          </a:xfrm>
+          <a:prstGeom prst="rect">
+            <a:avLst/>
+          </a:prstGeom>
+          <a:noFill/>
+          <a:ln/>
+        </p:spPr>
+        <p:txBody>
+          <a:bodyPr wrap="square" rtlCol="0" anchor="t"/>
+          <a:lstStyle/>
+          <a:p>
+            <a:pPr indent="0" marL="0">
+              <a:buNone/>
+            </a:pPr>
+            <a:r>
+              <a:rPr lang="en-US" sz="900" b="1" dirty="0">
+                <a:solidFill>
+                  <a:srgbClr val="9333EA"/>
+                </a:solidFill>
+                <a:latin typeface="Segoe UI" pitchFamily="34" charset="0"/>
+                <a:ea typeface="Segoe UI" pitchFamily="34" charset="-122"/>
+                <a:cs typeface="Segoe UI" pitchFamily="34" charset="-120"/>
+              </a:rPr>
+              <a:t>🔒 PERMISSIONS REQUIRED</a:t>
+            </a:r>
+            <a:endParaRPr lang="en-US" sz="900" dirty="0"/>
+          </a:p>
+          <a:p>
+            <a:pPr indent="0" marL="0">
+              <a:buNone/>
+            </a:pPr>
+            <a:r>
+              <a:rPr lang="en-US" sz="900" b="1" dirty="0">
+                <a:solidFill>
+                  <a:srgbClr val="17255A"/>
+                </a:solidFill>
+                <a:latin typeface="Segoe UI" pitchFamily="34" charset="0"/>
+                <a:ea typeface="Segoe UI" pitchFamily="34" charset="-122"/>
+                <a:cs typeface="Segoe UI" pitchFamily="34" charset="-120"/>
+              </a:rPr>
+              <a:t>Role: Key Vault Secrets Officer</a:t>
+            </a:r>
+            <a:endParaRPr lang="en-US" sz="900" dirty="0"/>
+          </a:p>
+          <a:p>
+            <a:pPr indent="0" marL="0">
+              <a:buNone/>
+            </a:pPr>
+            <a:r>
+              <a:rPr lang="en-US" sz="900" dirty="0">
+                <a:solidFill>
+                  <a:srgbClr val="17255A"/>
+                </a:solidFill>
+                <a:latin typeface="Segoe UI" pitchFamily="34" charset="0"/>
+                <a:ea typeface="Segoe UI" pitchFamily="34" charset="-122"/>
+                <a:cs typeface="Segoe UI" pitchFamily="34" charset="-120"/>
+              </a:rPr>
+              <a:t>• Key Vault Administrator or Secrets Officer</a:t>
+            </a:r>
+            <a:endParaRPr lang="en-US" sz="900" dirty="0"/>
+          </a:p>
+          <a:p>
+            <a:pPr indent="0" marL="0">
+              <a:buNone/>
+            </a:pPr>
+            <a:r>
+              <a:rPr lang="en-US" sz="900" dirty="0">
+                <a:solidFill>
+                  <a:srgbClr val="17255A"/>
+                </a:solidFill>
+                <a:latin typeface="Segoe UI" pitchFamily="34" charset="0"/>
+                <a:ea typeface="Segoe UI" pitchFamily="34" charset="-122"/>
+                <a:cs typeface="Segoe UI" pitchFamily="34" charset="-120"/>
+              </a:rPr>
+              <a:t>• Set secrets: DATABASE_URL, SESSION_SECRET</a:t>
+            </a:r>
+            <a:endParaRPr lang="en-US" sz="900" dirty="0"/>
+          </a:p>
+          <a:p>
+            <a:pPr indent="0" marL="0">
+              <a:buNone/>
+            </a:pPr>
+            <a:r>
+              <a:rPr lang="en-US" sz="900" dirty="0">
+                <a:solidFill>
+                  <a:srgbClr val="17255A"/>
+                </a:solidFill>
+                <a:latin typeface="Segoe UI" pitchFamily="34" charset="0"/>
+                <a:ea typeface="Segoe UI" pitchFamily="34" charset="-122"/>
+                <a:cs typeface="Segoe UI" pitchFamily="34" charset="-120"/>
+              </a:rPr>
+              <a:t>• Set secrets: GOOGLE/MICROSOFT OAuth credentials</a:t>
+            </a:r>
+            <a:endParaRPr lang="en-US" sz="900" dirty="0"/>
+          </a:p>
+          <a:p>
+            <a:pPr indent="0" marL="0">
+              <a:buNone/>
+            </a:pPr>
+            <a:r>
+              <a:rPr lang="en-US" sz="900" dirty="0">
+                <a:solidFill>
+                  <a:srgbClr val="17255A"/>
+                </a:solidFill>
+                <a:latin typeface="Segoe UI" pitchFamily="34" charset="0"/>
+                <a:ea typeface="Segoe UI" pitchFamily="34" charset="-122"/>
+                <a:cs typeface="Segoe UI" pitchFamily="34" charset="-120"/>
+              </a:rPr>
+              <a:t>• Set secrets: RESEND_API_KEY</a:t>
+            </a:r>
+            <a:endParaRPr lang="en-US" sz="900" dirty="0"/>
+          </a:p>
+          <a:p>
+            <a:pPr indent="0" marL="0">
+              <a:buNone/>
+            </a:pPr>
+            <a:r>
+              <a:rPr lang="en-US" sz="900" dirty="0">
+                <a:solidFill>
+                  <a:srgbClr val="17255A"/>
+                </a:solidFill>
+                <a:latin typeface="Segoe UI" pitchFamily="34" charset="0"/>
+                <a:ea typeface="Segoe UI" pitchFamily="34" charset="-122"/>
+                <a:cs typeface="Segoe UI" pitchFamily="34" charset="-120"/>
+              </a:rPr>
+              <a:t>• Uses Azure RBAC (not vault access policies)</a:t>
+            </a:r>
+            <a:endParaRPr lang="en-US" sz="900" dirty="0"/>
+          </a:p>
+        </p:txBody>
+      </p:sp>
     </p:spTree>
   </p:cSld>
   <p:clrMapOvr>
@@ -6049,6 +7092,502 @@
           </a:p>
         </p:txBody>
       </p:sp>
+      <p:sp>
+        <p:nvSpPr>
+          <p:cNvPr id="23" name="Shape 21"/>
+          <p:cNvSpPr/>
+          <p:nvPr/>
+        </p:nvSpPr>
+        <p:spPr>
+          <a:xfrm>
+            <a:off x="548640" y="4572000"/>
+            <a:ext cx="3474720" cy="1024128"/>
+          </a:xfrm>
+          <a:prstGeom prst="rect">
+            <a:avLst>
+              <a:gd name="adj" fmla="val 5357"/>
+            </a:avLst>
+          </a:prstGeom>
+          <a:solidFill>
+            <a:srgbClr val="FAF5FF"/>
+          </a:solidFill>
+          <a:ln w="25400">
+            <a:solidFill>
+              <a:srgbClr val="9333EA"/>
+            </a:solidFill>
+            <a:prstDash val="solid"/>
+          </a:ln>
+        </p:spPr>
+      </p:sp>
+      <p:sp>
+        <p:nvSpPr>
+          <p:cNvPr id="24" name="Shape 22"/>
+          <p:cNvSpPr/>
+          <p:nvPr/>
+        </p:nvSpPr>
+        <p:spPr>
+          <a:xfrm>
+            <a:off x="548640" y="4572000"/>
+            <a:ext cx="3474720" cy="54864"/>
+          </a:xfrm>
+          <a:prstGeom prst="rect">
+            <a:avLst/>
+          </a:prstGeom>
+          <a:solidFill>
+            <a:srgbClr val="9333EA"/>
+          </a:solidFill>
+          <a:ln/>
+        </p:spPr>
+      </p:sp>
+      <p:sp>
+        <p:nvSpPr>
+          <p:cNvPr id="25" name="Text 23"/>
+          <p:cNvSpPr/>
+          <p:nvPr/>
+        </p:nvSpPr>
+        <p:spPr>
+          <a:xfrm>
+            <a:off x="658368" y="4645152"/>
+            <a:ext cx="3255264" cy="877824"/>
+          </a:xfrm>
+          <a:prstGeom prst="rect">
+            <a:avLst/>
+          </a:prstGeom>
+          <a:noFill/>
+          <a:ln/>
+        </p:spPr>
+        <p:txBody>
+          <a:bodyPr wrap="square" rtlCol="0" anchor="t"/>
+          <a:lstStyle/>
+          <a:p>
+            <a:pPr indent="0" marL="0">
+              <a:buNone/>
+            </a:pPr>
+            <a:r>
+              <a:rPr lang="en-US" sz="900" b="1" dirty="0">
+                <a:solidFill>
+                  <a:srgbClr val="9333EA"/>
+                </a:solidFill>
+                <a:latin typeface="Segoe UI" pitchFamily="34" charset="0"/>
+                <a:ea typeface="Segoe UI" pitchFamily="34" charset="-122"/>
+                <a:cs typeface="Segoe UI" pitchFamily="34" charset="-120"/>
+              </a:rPr>
+              <a:t>🔒 PERMISSIONS REQUIRED</a:t>
+            </a:r>
+            <a:endParaRPr lang="en-US" sz="900" dirty="0"/>
+          </a:p>
+          <a:p>
+            <a:pPr indent="0" marL="0">
+              <a:buNone/>
+            </a:pPr>
+            <a:r>
+              <a:rPr lang="en-US" sz="900" b="1" dirty="0">
+                <a:solidFill>
+                  <a:srgbClr val="17255A"/>
+                </a:solidFill>
+                <a:latin typeface="Segoe UI" pitchFamily="34" charset="0"/>
+                <a:ea typeface="Segoe UI" pitchFamily="34" charset="-122"/>
+                <a:cs typeface="Segoe UI" pitchFamily="34" charset="-120"/>
+              </a:rPr>
+              <a:t>Role: Container App Deployer</a:t>
+            </a:r>
+            <a:endParaRPr lang="en-US" sz="900" dirty="0"/>
+          </a:p>
+          <a:p>
+            <a:pPr indent="0" marL="0">
+              <a:buNone/>
+            </a:pPr>
+            <a:r>
+              <a:rPr lang="en-US" sz="900" dirty="0">
+                <a:solidFill>
+                  <a:srgbClr val="17255A"/>
+                </a:solidFill>
+                <a:latin typeface="Segoe UI" pitchFamily="34" charset="0"/>
+                <a:ea typeface="Segoe UI" pitchFamily="34" charset="-122"/>
+                <a:cs typeface="Segoe UI" pitchFamily="34" charset="-120"/>
+              </a:rPr>
+              <a:t>• Contributor on Container App Environment</a:t>
+            </a:r>
+            <a:endParaRPr lang="en-US" sz="900" dirty="0"/>
+          </a:p>
+          <a:p>
+            <a:pPr indent="0" marL="0">
+              <a:buNone/>
+            </a:pPr>
+            <a:r>
+              <a:rPr lang="en-US" sz="900" dirty="0">
+                <a:solidFill>
+                  <a:srgbClr val="17255A"/>
+                </a:solidFill>
+                <a:latin typeface="Segoe UI" pitchFamily="34" charset="0"/>
+                <a:ea typeface="Segoe UI" pitchFamily="34" charset="-122"/>
+                <a:cs typeface="Segoe UI" pitchFamily="34" charset="-120"/>
+              </a:rPr>
+              <a:t>• Microsoft.App/containerApps/* — Create/update apps</a:t>
+            </a:r>
+            <a:endParaRPr lang="en-US" sz="900" dirty="0"/>
+          </a:p>
+          <a:p>
+            <a:pPr indent="0" marL="0">
+              <a:buNone/>
+            </a:pPr>
+            <a:r>
+              <a:rPr lang="en-US" sz="900" dirty="0">
+                <a:solidFill>
+                  <a:srgbClr val="17255A"/>
+                </a:solidFill>
+                <a:latin typeface="Segoe UI" pitchFamily="34" charset="0"/>
+                <a:ea typeface="Segoe UI" pitchFamily="34" charset="-122"/>
+                <a:cs typeface="Segoe UI" pitchFamily="34" charset="-120"/>
+              </a:rPr>
+              <a:t>• AcrPull on ACR (assigned to app's Managed Identity)</a:t>
+            </a:r>
+            <a:endParaRPr lang="en-US" sz="900" dirty="0"/>
+          </a:p>
+        </p:txBody>
+      </p:sp>
+      <p:sp>
+        <p:nvSpPr>
+          <p:cNvPr id="26" name="Shape 24"/>
+          <p:cNvSpPr/>
+          <p:nvPr/>
+        </p:nvSpPr>
+        <p:spPr>
+          <a:xfrm>
+            <a:off x="4389120" y="4572000"/>
+            <a:ext cx="3474720" cy="1225296"/>
+          </a:xfrm>
+          <a:prstGeom prst="rect">
+            <a:avLst>
+              <a:gd name="adj" fmla="val 4478"/>
+            </a:avLst>
+          </a:prstGeom>
+          <a:solidFill>
+            <a:srgbClr val="FAF5FF"/>
+          </a:solidFill>
+          <a:ln w="25400">
+            <a:solidFill>
+              <a:srgbClr val="9333EA"/>
+            </a:solidFill>
+            <a:prstDash val="solid"/>
+          </a:ln>
+        </p:spPr>
+      </p:sp>
+      <p:sp>
+        <p:nvSpPr>
+          <p:cNvPr id="27" name="Shape 25"/>
+          <p:cNvSpPr/>
+          <p:nvPr/>
+        </p:nvSpPr>
+        <p:spPr>
+          <a:xfrm>
+            <a:off x="4389120" y="4572000"/>
+            <a:ext cx="3474720" cy="54864"/>
+          </a:xfrm>
+          <a:prstGeom prst="rect">
+            <a:avLst/>
+          </a:prstGeom>
+          <a:solidFill>
+            <a:srgbClr val="9333EA"/>
+          </a:solidFill>
+          <a:ln/>
+        </p:spPr>
+      </p:sp>
+      <p:sp>
+        <p:nvSpPr>
+          <p:cNvPr id="28" name="Text 26"/>
+          <p:cNvSpPr/>
+          <p:nvPr/>
+        </p:nvSpPr>
+        <p:spPr>
+          <a:xfrm>
+            <a:off x="4498848" y="4645152"/>
+            <a:ext cx="3255264" cy="1078992"/>
+          </a:xfrm>
+          <a:prstGeom prst="rect">
+            <a:avLst/>
+          </a:prstGeom>
+          <a:noFill/>
+          <a:ln/>
+        </p:spPr>
+        <p:txBody>
+          <a:bodyPr wrap="square" rtlCol="0" anchor="t"/>
+          <a:lstStyle/>
+          <a:p>
+            <a:pPr indent="0" marL="0">
+              <a:buNone/>
+            </a:pPr>
+            <a:r>
+              <a:rPr lang="en-US" sz="900" b="1" dirty="0">
+                <a:solidFill>
+                  <a:srgbClr val="9333EA"/>
+                </a:solidFill>
+                <a:latin typeface="Segoe UI" pitchFamily="34" charset="0"/>
+                <a:ea typeface="Segoe UI" pitchFamily="34" charset="-122"/>
+                <a:cs typeface="Segoe UI" pitchFamily="34" charset="-120"/>
+              </a:rPr>
+              <a:t>🔒 PERMISSIONS REQUIRED</a:t>
+            </a:r>
+            <a:endParaRPr lang="en-US" sz="900" dirty="0"/>
+          </a:p>
+          <a:p>
+            <a:pPr indent="0" marL="0">
+              <a:buNone/>
+            </a:pPr>
+            <a:r>
+              <a:rPr lang="en-US" sz="900" b="1" dirty="0">
+                <a:solidFill>
+                  <a:srgbClr val="17255A"/>
+                </a:solidFill>
+                <a:latin typeface="Segoe UI" pitchFamily="34" charset="0"/>
+                <a:ea typeface="Segoe UI" pitchFamily="34" charset="-122"/>
+                <a:cs typeface="Segoe UI" pitchFamily="34" charset="-120"/>
+              </a:rPr>
+              <a:t>Role: Identity &amp; Role Admin</a:t>
+            </a:r>
+            <a:endParaRPr lang="en-US" sz="900" dirty="0"/>
+          </a:p>
+          <a:p>
+            <a:pPr indent="0" marL="0">
+              <a:buNone/>
+            </a:pPr>
+            <a:r>
+              <a:rPr lang="en-US" sz="900" dirty="0">
+                <a:solidFill>
+                  <a:srgbClr val="17255A"/>
+                </a:solidFill>
+                <a:latin typeface="Segoe UI" pitchFamily="34" charset="0"/>
+                <a:ea typeface="Segoe UI" pitchFamily="34" charset="-122"/>
+                <a:cs typeface="Segoe UI" pitchFamily="34" charset="-120"/>
+              </a:rPr>
+              <a:t>• User Access Administrator on Resource Group</a:t>
+            </a:r>
+            <a:endParaRPr lang="en-US" sz="900" dirty="0"/>
+          </a:p>
+          <a:p>
+            <a:pPr indent="0" marL="0">
+              <a:buNone/>
+            </a:pPr>
+            <a:r>
+              <a:rPr lang="en-US" sz="900" dirty="0">
+                <a:solidFill>
+                  <a:srgbClr val="17255A"/>
+                </a:solidFill>
+                <a:latin typeface="Segoe UI" pitchFamily="34" charset="0"/>
+                <a:ea typeface="Segoe UI" pitchFamily="34" charset="-122"/>
+                <a:cs typeface="Segoe UI" pitchFamily="34" charset="-120"/>
+              </a:rPr>
+              <a:t>• Assign AcrPull to Container App identity</a:t>
+            </a:r>
+            <a:endParaRPr lang="en-US" sz="900" dirty="0"/>
+          </a:p>
+          <a:p>
+            <a:pPr indent="0" marL="0">
+              <a:buNone/>
+            </a:pPr>
+            <a:r>
+              <a:rPr lang="en-US" sz="900" dirty="0">
+                <a:solidFill>
+                  <a:srgbClr val="17255A"/>
+                </a:solidFill>
+                <a:latin typeface="Segoe UI" pitchFamily="34" charset="0"/>
+                <a:ea typeface="Segoe UI" pitchFamily="34" charset="-122"/>
+                <a:cs typeface="Segoe UI" pitchFamily="34" charset="-120"/>
+              </a:rPr>
+              <a:t>• Assign Key Vault Secrets User to app identity</a:t>
+            </a:r>
+            <a:endParaRPr lang="en-US" sz="900" dirty="0"/>
+          </a:p>
+          <a:p>
+            <a:pPr indent="0" marL="0">
+              <a:buNone/>
+            </a:pPr>
+            <a:r>
+              <a:rPr lang="en-US" sz="900" dirty="0">
+                <a:solidFill>
+                  <a:srgbClr val="17255A"/>
+                </a:solidFill>
+                <a:latin typeface="Segoe UI" pitchFamily="34" charset="0"/>
+                <a:ea typeface="Segoe UI" pitchFamily="34" charset="-122"/>
+                <a:cs typeface="Segoe UI" pitchFamily="34" charset="-120"/>
+              </a:rPr>
+              <a:t>• Assign Storage Blob Data Contributor to app identity</a:t>
+            </a:r>
+            <a:endParaRPr lang="en-US" sz="900" dirty="0"/>
+          </a:p>
+        </p:txBody>
+      </p:sp>
+      <p:sp>
+        <p:nvSpPr>
+          <p:cNvPr id="29" name="Shape 27"/>
+          <p:cNvSpPr/>
+          <p:nvPr/>
+        </p:nvSpPr>
+        <p:spPr>
+          <a:xfrm>
+            <a:off x="8229600" y="4572000"/>
+            <a:ext cx="3474720" cy="1225296"/>
+          </a:xfrm>
+          <a:prstGeom prst="rect">
+            <a:avLst>
+              <a:gd name="adj" fmla="val 4478"/>
+            </a:avLst>
+          </a:prstGeom>
+          <a:solidFill>
+            <a:srgbClr val="FAF5FF"/>
+          </a:solidFill>
+          <a:ln w="25400">
+            <a:solidFill>
+              <a:srgbClr val="9333EA"/>
+            </a:solidFill>
+            <a:prstDash val="solid"/>
+          </a:ln>
+        </p:spPr>
+      </p:sp>
+      <p:sp>
+        <p:nvSpPr>
+          <p:cNvPr id="30" name="Shape 28"/>
+          <p:cNvSpPr/>
+          <p:nvPr/>
+        </p:nvSpPr>
+        <p:spPr>
+          <a:xfrm>
+            <a:off x="8229600" y="4572000"/>
+            <a:ext cx="3474720" cy="54864"/>
+          </a:xfrm>
+          <a:prstGeom prst="rect">
+            <a:avLst/>
+          </a:prstGeom>
+          <a:solidFill>
+            <a:srgbClr val="9333EA"/>
+          </a:solidFill>
+          <a:ln/>
+        </p:spPr>
+      </p:sp>
+      <p:sp>
+        <p:nvSpPr>
+          <p:cNvPr id="31" name="Text 29"/>
+          <p:cNvSpPr/>
+          <p:nvPr/>
+        </p:nvSpPr>
+        <p:spPr>
+          <a:xfrm>
+            <a:off x="8339328" y="4645152"/>
+            <a:ext cx="3255264" cy="1078992"/>
+          </a:xfrm>
+          <a:prstGeom prst="rect">
+            <a:avLst/>
+          </a:prstGeom>
+          <a:noFill/>
+          <a:ln/>
+        </p:spPr>
+        <p:txBody>
+          <a:bodyPr wrap="square" rtlCol="0" anchor="t"/>
+          <a:lstStyle/>
+          <a:p>
+            <a:pPr indent="0" marL="0">
+              <a:buNone/>
+            </a:pPr>
+            <a:r>
+              <a:rPr lang="en-US" sz="900" b="1" dirty="0">
+                <a:solidFill>
+                  <a:srgbClr val="9333EA"/>
+                </a:solidFill>
+                <a:latin typeface="Segoe UI" pitchFamily="34" charset="0"/>
+                <a:ea typeface="Segoe UI" pitchFamily="34" charset="-122"/>
+                <a:cs typeface="Segoe UI" pitchFamily="34" charset="-120"/>
+              </a:rPr>
+              <a:t>🔒 PERMISSIONS REQUIRED</a:t>
+            </a:r>
+            <a:endParaRPr lang="en-US" sz="900" dirty="0"/>
+          </a:p>
+          <a:p>
+            <a:pPr indent="0" marL="0">
+              <a:buNone/>
+            </a:pPr>
+            <a:r>
+              <a:rPr lang="en-US" sz="900" b="1" dirty="0">
+                <a:solidFill>
+                  <a:srgbClr val="17255A"/>
+                </a:solidFill>
+                <a:latin typeface="Segoe UI" pitchFamily="34" charset="0"/>
+                <a:ea typeface="Segoe UI" pitchFamily="34" charset="-122"/>
+                <a:cs typeface="Segoe UI" pitchFamily="34" charset="-120"/>
+              </a:rPr>
+              <a:t>Role: DNS Administrator</a:t>
+            </a:r>
+            <a:endParaRPr lang="en-US" sz="900" dirty="0"/>
+          </a:p>
+          <a:p>
+            <a:pPr indent="0" marL="0">
+              <a:buNone/>
+            </a:pPr>
+            <a:r>
+              <a:rPr lang="en-US" sz="900" dirty="0">
+                <a:solidFill>
+                  <a:srgbClr val="17255A"/>
+                </a:solidFill>
+                <a:latin typeface="Segoe UI" pitchFamily="34" charset="0"/>
+                <a:ea typeface="Segoe UI" pitchFamily="34" charset="-122"/>
+                <a:cs typeface="Segoe UI" pitchFamily="34" charset="-120"/>
+              </a:rPr>
+              <a:t>• DNS zone management (external registrar)</a:t>
+            </a:r>
+            <a:endParaRPr lang="en-US" sz="900" dirty="0"/>
+          </a:p>
+          <a:p>
+            <a:pPr indent="0" marL="0">
+              <a:buNone/>
+            </a:pPr>
+            <a:r>
+              <a:rPr lang="en-US" sz="900" dirty="0">
+                <a:solidFill>
+                  <a:srgbClr val="17255A"/>
+                </a:solidFill>
+                <a:latin typeface="Segoe UI" pitchFamily="34" charset="0"/>
+                <a:ea typeface="Segoe UI" pitchFamily="34" charset="-122"/>
+                <a:cs typeface="Segoe UI" pitchFamily="34" charset="-120"/>
+              </a:rPr>
+              <a:t>• Create CNAME and TXT records</a:t>
+            </a:r>
+            <a:endParaRPr lang="en-US" sz="900" dirty="0"/>
+          </a:p>
+          <a:p>
+            <a:pPr indent="0" marL="0">
+              <a:buNone/>
+            </a:pPr>
+            <a:r>
+              <a:rPr lang="en-US" sz="900" dirty="0">
+                <a:solidFill>
+                  <a:srgbClr val="17255A"/>
+                </a:solidFill>
+                <a:latin typeface="Segoe UI" pitchFamily="34" charset="0"/>
+                <a:ea typeface="Segoe UI" pitchFamily="34" charset="-122"/>
+                <a:cs typeface="Segoe UI" pitchFamily="34" charset="-120"/>
+              </a:rPr>
+              <a:t>• Google Cloud Console access (OAuth config)</a:t>
+            </a:r>
+            <a:endParaRPr lang="en-US" sz="900" dirty="0"/>
+          </a:p>
+          <a:p>
+            <a:pPr indent="0" marL="0">
+              <a:buNone/>
+            </a:pPr>
+            <a:r>
+              <a:rPr lang="en-US" sz="900" dirty="0">
+                <a:solidFill>
+                  <a:srgbClr val="17255A"/>
+                </a:solidFill>
+                <a:latin typeface="Segoe UI" pitchFamily="34" charset="0"/>
+                <a:ea typeface="Segoe UI" pitchFamily="34" charset="-122"/>
+                <a:cs typeface="Segoe UI" pitchFamily="34" charset="-120"/>
+              </a:rPr>
+              <a:t>• Azure Portal: App Registrations (Entra ID)</a:t>
+            </a:r>
+            <a:endParaRPr lang="en-US" sz="900" dirty="0"/>
+          </a:p>
+        </p:txBody>
+      </p:sp>
     </p:spTree>
   </p:cSld>
   <p:clrMapOvr>
@@ -7541,6 +9080,348 @@
               <a:t>• Alert on container restart count</a:t>
             </a:r>
             <a:endParaRPr lang="en-US" sz="1100" dirty="0"/>
+          </a:p>
+        </p:txBody>
+      </p:sp>
+      <p:sp>
+        <p:nvSpPr>
+          <p:cNvPr id="36" name="Shape 34"/>
+          <p:cNvSpPr/>
+          <p:nvPr/>
+        </p:nvSpPr>
+        <p:spPr>
+          <a:xfrm>
+            <a:off x="548640" y="5486400"/>
+            <a:ext cx="5486400" cy="1225296"/>
+          </a:xfrm>
+          <a:prstGeom prst="rect">
+            <a:avLst>
+              <a:gd name="adj" fmla="val 4478"/>
+            </a:avLst>
+          </a:prstGeom>
+          <a:solidFill>
+            <a:srgbClr val="FAF5FF"/>
+          </a:solidFill>
+          <a:ln w="25400">
+            <a:solidFill>
+              <a:srgbClr val="9333EA"/>
+            </a:solidFill>
+            <a:prstDash val="solid"/>
+          </a:ln>
+        </p:spPr>
+      </p:sp>
+      <p:sp>
+        <p:nvSpPr>
+          <p:cNvPr id="37" name="Shape 35"/>
+          <p:cNvSpPr/>
+          <p:nvPr/>
+        </p:nvSpPr>
+        <p:spPr>
+          <a:xfrm>
+            <a:off x="548640" y="5486400"/>
+            <a:ext cx="5486400" cy="54864"/>
+          </a:xfrm>
+          <a:prstGeom prst="rect">
+            <a:avLst/>
+          </a:prstGeom>
+          <a:solidFill>
+            <a:srgbClr val="9333EA"/>
+          </a:solidFill>
+          <a:ln/>
+        </p:spPr>
+      </p:sp>
+      <p:sp>
+        <p:nvSpPr>
+          <p:cNvPr id="38" name="Text 36"/>
+          <p:cNvSpPr/>
+          <p:nvPr/>
+        </p:nvSpPr>
+        <p:spPr>
+          <a:xfrm>
+            <a:off x="658368" y="5559552"/>
+            <a:ext cx="5266944" cy="1078992"/>
+          </a:xfrm>
+          <a:prstGeom prst="rect">
+            <a:avLst/>
+          </a:prstGeom>
+          <a:noFill/>
+          <a:ln/>
+        </p:spPr>
+        <p:txBody>
+          <a:bodyPr wrap="square" rtlCol="0" anchor="t"/>
+          <a:lstStyle/>
+          <a:p>
+            <a:pPr indent="0" marL="0">
+              <a:buNone/>
+            </a:pPr>
+            <a:r>
+              <a:rPr lang="en-US" sz="900" b="1" dirty="0">
+                <a:solidFill>
+                  <a:srgbClr val="9333EA"/>
+                </a:solidFill>
+                <a:latin typeface="Segoe UI" pitchFamily="34" charset="0"/>
+                <a:ea typeface="Segoe UI" pitchFamily="34" charset="-122"/>
+                <a:cs typeface="Segoe UI" pitchFamily="34" charset="-120"/>
+              </a:rPr>
+              <a:t>🔒 PERMISSIONS REQUIRED</a:t>
+            </a:r>
+            <a:endParaRPr lang="en-US" sz="900" dirty="0"/>
+          </a:p>
+          <a:p>
+            <a:pPr indent="0" marL="0">
+              <a:buNone/>
+            </a:pPr>
+            <a:r>
+              <a:rPr lang="en-US" sz="900" b="1" dirty="0">
+                <a:solidFill>
+                  <a:srgbClr val="17255A"/>
+                </a:solidFill>
+                <a:latin typeface="Segoe UI" pitchFamily="34" charset="0"/>
+                <a:ea typeface="Segoe UI" pitchFamily="34" charset="-122"/>
+                <a:cs typeface="Segoe UI" pitchFamily="34" charset="-120"/>
+              </a:rPr>
+              <a:t>Role: Container App Managed Identity (runtime)</a:t>
+            </a:r>
+            <a:endParaRPr lang="en-US" sz="900" dirty="0"/>
+          </a:p>
+          <a:p>
+            <a:pPr indent="0" marL="0">
+              <a:buNone/>
+            </a:pPr>
+            <a:r>
+              <a:rPr lang="en-US" sz="900" dirty="0">
+                <a:solidFill>
+                  <a:srgbClr val="17255A"/>
+                </a:solidFill>
+                <a:latin typeface="Segoe UI" pitchFamily="34" charset="0"/>
+                <a:ea typeface="Segoe UI" pitchFamily="34" charset="-122"/>
+                <a:cs typeface="Segoe UI" pitchFamily="34" charset="-120"/>
+              </a:rPr>
+              <a:t>• AcrPull — Pull container images on restart/scale-out</a:t>
+            </a:r>
+            <a:endParaRPr lang="en-US" sz="900" dirty="0"/>
+          </a:p>
+          <a:p>
+            <a:pPr indent="0" marL="0">
+              <a:buNone/>
+            </a:pPr>
+            <a:r>
+              <a:rPr lang="en-US" sz="900" dirty="0">
+                <a:solidFill>
+                  <a:srgbClr val="17255A"/>
+                </a:solidFill>
+                <a:latin typeface="Segoe UI" pitchFamily="34" charset="0"/>
+                <a:ea typeface="Segoe UI" pitchFamily="34" charset="-122"/>
+                <a:cs typeface="Segoe UI" pitchFamily="34" charset="-120"/>
+              </a:rPr>
+              <a:t>• Key Vault Secrets User — Read secrets at startup</a:t>
+            </a:r>
+            <a:endParaRPr lang="en-US" sz="900" dirty="0"/>
+          </a:p>
+          <a:p>
+            <a:pPr indent="0" marL="0">
+              <a:buNone/>
+            </a:pPr>
+            <a:r>
+              <a:rPr lang="en-US" sz="900" dirty="0">
+                <a:solidFill>
+                  <a:srgbClr val="17255A"/>
+                </a:solidFill>
+                <a:latin typeface="Segoe UI" pitchFamily="34" charset="0"/>
+                <a:ea typeface="Segoe UI" pitchFamily="34" charset="-122"/>
+                <a:cs typeface="Segoe UI" pitchFamily="34" charset="-120"/>
+              </a:rPr>
+              <a:t>• Storage Blob Data Contributor — Read/write file uploads</a:t>
+            </a:r>
+            <a:endParaRPr lang="en-US" sz="900" dirty="0"/>
+          </a:p>
+          <a:p>
+            <a:pPr indent="0" marL="0">
+              <a:buNone/>
+            </a:pPr>
+            <a:r>
+              <a:rPr lang="en-US" sz="900" dirty="0">
+                <a:solidFill>
+                  <a:srgbClr val="17255A"/>
+                </a:solidFill>
+                <a:latin typeface="Segoe UI" pitchFamily="34" charset="0"/>
+                <a:ea typeface="Segoe UI" pitchFamily="34" charset="-122"/>
+                <a:cs typeface="Segoe UI" pitchFamily="34" charset="-120"/>
+              </a:rPr>
+              <a:t>• PostgreSQL access via DATABASE_URL connection string (not RBAC)</a:t>
+            </a:r>
+            <a:endParaRPr lang="en-US" sz="900" dirty="0"/>
+          </a:p>
+        </p:txBody>
+      </p:sp>
+      <p:sp>
+        <p:nvSpPr>
+          <p:cNvPr id="39" name="Shape 37"/>
+          <p:cNvSpPr/>
+          <p:nvPr/>
+        </p:nvSpPr>
+        <p:spPr>
+          <a:xfrm>
+            <a:off x="6400800" y="5486400"/>
+            <a:ext cx="5212080" cy="1225296"/>
+          </a:xfrm>
+          <a:prstGeom prst="rect">
+            <a:avLst>
+              <a:gd name="adj" fmla="val 4478"/>
+            </a:avLst>
+          </a:prstGeom>
+          <a:solidFill>
+            <a:srgbClr val="FAF5FF"/>
+          </a:solidFill>
+          <a:ln w="25400">
+            <a:solidFill>
+              <a:srgbClr val="9333EA"/>
+            </a:solidFill>
+            <a:prstDash val="solid"/>
+          </a:ln>
+        </p:spPr>
+      </p:sp>
+      <p:sp>
+        <p:nvSpPr>
+          <p:cNvPr id="40" name="Shape 38"/>
+          <p:cNvSpPr/>
+          <p:nvPr/>
+        </p:nvSpPr>
+        <p:spPr>
+          <a:xfrm>
+            <a:off x="6400800" y="5486400"/>
+            <a:ext cx="5212080" cy="54864"/>
+          </a:xfrm>
+          <a:prstGeom prst="rect">
+            <a:avLst/>
+          </a:prstGeom>
+          <a:solidFill>
+            <a:srgbClr val="9333EA"/>
+          </a:solidFill>
+          <a:ln/>
+        </p:spPr>
+      </p:sp>
+      <p:sp>
+        <p:nvSpPr>
+          <p:cNvPr id="41" name="Text 39"/>
+          <p:cNvSpPr/>
+          <p:nvPr/>
+        </p:nvSpPr>
+        <p:spPr>
+          <a:xfrm>
+            <a:off x="6510528" y="5559552"/>
+            <a:ext cx="4992624" cy="1078992"/>
+          </a:xfrm>
+          <a:prstGeom prst="rect">
+            <a:avLst/>
+          </a:prstGeom>
+          <a:noFill/>
+          <a:ln/>
+        </p:spPr>
+        <p:txBody>
+          <a:bodyPr wrap="square" rtlCol="0" anchor="t"/>
+          <a:lstStyle/>
+          <a:p>
+            <a:pPr indent="0" marL="0">
+              <a:buNone/>
+            </a:pPr>
+            <a:r>
+              <a:rPr lang="en-US" sz="900" b="1" dirty="0">
+                <a:solidFill>
+                  <a:srgbClr val="9333EA"/>
+                </a:solidFill>
+                <a:latin typeface="Segoe UI" pitchFamily="34" charset="0"/>
+                <a:ea typeface="Segoe UI" pitchFamily="34" charset="-122"/>
+                <a:cs typeface="Segoe UI" pitchFamily="34" charset="-120"/>
+              </a:rPr>
+              <a:t>🔒 PERMISSIONS REQUIRED</a:t>
+            </a:r>
+            <a:endParaRPr lang="en-US" sz="900" dirty="0"/>
+          </a:p>
+          <a:p>
+            <a:pPr indent="0" marL="0">
+              <a:buNone/>
+            </a:pPr>
+            <a:r>
+              <a:rPr lang="en-US" sz="900" b="1" dirty="0">
+                <a:solidFill>
+                  <a:srgbClr val="17255A"/>
+                </a:solidFill>
+                <a:latin typeface="Segoe UI" pitchFamily="34" charset="0"/>
+                <a:ea typeface="Segoe UI" pitchFamily="34" charset="-122"/>
+                <a:cs typeface="Segoe UI" pitchFamily="34" charset="-120"/>
+              </a:rPr>
+              <a:t>Role: Operations / SRE Team</a:t>
+            </a:r>
+            <a:endParaRPr lang="en-US" sz="900" dirty="0"/>
+          </a:p>
+          <a:p>
+            <a:pPr indent="0" marL="0">
+              <a:buNone/>
+            </a:pPr>
+            <a:r>
+              <a:rPr lang="en-US" sz="900" dirty="0">
+                <a:solidFill>
+                  <a:srgbClr val="17255A"/>
+                </a:solidFill>
+                <a:latin typeface="Segoe UI" pitchFamily="34" charset="0"/>
+                <a:ea typeface="Segoe UI" pitchFamily="34" charset="-122"/>
+                <a:cs typeface="Segoe UI" pitchFamily="34" charset="-120"/>
+              </a:rPr>
+              <a:t>• Reader on Resource Group — View all resources</a:t>
+            </a:r>
+            <a:endParaRPr lang="en-US" sz="900" dirty="0"/>
+          </a:p>
+          <a:p>
+            <a:pPr indent="0" marL="0">
+              <a:buNone/>
+            </a:pPr>
+            <a:r>
+              <a:rPr lang="en-US" sz="900" dirty="0">
+                <a:solidFill>
+                  <a:srgbClr val="17255A"/>
+                </a:solidFill>
+                <a:latin typeface="Segoe UI" pitchFamily="34" charset="0"/>
+                <a:ea typeface="Segoe UI" pitchFamily="34" charset="-122"/>
+                <a:cs typeface="Segoe UI" pitchFamily="34" charset="-120"/>
+              </a:rPr>
+              <a:t>• Log Analytics Reader — Query logs and dashboards</a:t>
+            </a:r>
+            <a:endParaRPr lang="en-US" sz="900" dirty="0"/>
+          </a:p>
+          <a:p>
+            <a:pPr indent="0" marL="0">
+              <a:buNone/>
+            </a:pPr>
+            <a:r>
+              <a:rPr lang="en-US" sz="900" dirty="0">
+                <a:solidFill>
+                  <a:srgbClr val="17255A"/>
+                </a:solidFill>
+                <a:latin typeface="Segoe UI" pitchFamily="34" charset="0"/>
+                <a:ea typeface="Segoe UI" pitchFamily="34" charset="-122"/>
+                <a:cs typeface="Segoe UI" pitchFamily="34" charset="-120"/>
+              </a:rPr>
+              <a:t>• Container App Contributor — Restart, scale, update revisions</a:t>
+            </a:r>
+            <a:endParaRPr lang="en-US" sz="900" dirty="0"/>
+          </a:p>
+          <a:p>
+            <a:pPr indent="0" marL="0">
+              <a:buNone/>
+            </a:pPr>
+            <a:r>
+              <a:rPr lang="en-US" sz="900" dirty="0">
+                <a:solidFill>
+                  <a:srgbClr val="17255A"/>
+                </a:solidFill>
+                <a:latin typeface="Segoe UI" pitchFamily="34" charset="0"/>
+                <a:ea typeface="Segoe UI" pitchFamily="34" charset="-122"/>
+                <a:cs typeface="Segoe UI" pitchFamily="34" charset="-120"/>
+              </a:rPr>
+              <a:t>• Monitoring Contributor — Create alerts and action groups</a:t>
+            </a:r>
+            <a:endParaRPr lang="en-US" sz="900" dirty="0"/>
           </a:p>
         </p:txBody>
       </p:sp>

</xml_diff>

<commit_message>
Update PowerPoint slides with Azure deployment flow details
Add details to PostgreSQL firewall settings and ingress/TLS configuration in the Azure Deployment Flow PowerPoint, updating the `scripts/generate-diagram-pptx.ts` file.

Replit-Commit-Author: Agent
Replit-Commit-Session-Id: 6d2574e3-cf59-4195-8e61-d725d2127375
Replit-Commit-Checkpoint-Type: full_checkpoint
Replit-Commit-Event-Id: 4da3e5f5-f15a-4f88-ba13-06facd0083eb
Replit-Helium-Checkpoint-Created: true
</commit_message>
<xml_diff>
--- a/FridayReportAI_Azure_Deployment_Flow.pptx
+++ b/FridayReportAI_Azure_Deployment_Flow.pptx
@@ -22875,11 +22875,11 @@
         <p:spPr>
           <a:xfrm>
             <a:off x="4389120" y="2560320"/>
-            <a:ext cx="3474720" cy="1389888"/>
+            <a:ext cx="3474720" cy="1591056"/>
           </a:xfrm>
           <a:prstGeom prst="rect">
             <a:avLst>
-              <a:gd name="adj" fmla="val 3947"/>
+              <a:gd name="adj" fmla="val 3448"/>
             </a:avLst>
           </a:prstGeom>
           <a:solidFill>
@@ -22922,7 +22922,7 @@
         <p:spPr>
           <a:xfrm>
             <a:off x="4498848" y="2651760"/>
-            <a:ext cx="3255264" cy="1207008"/>
+            <a:ext cx="3255264" cy="1408176"/>
           </a:xfrm>
           <a:prstGeom prst="rect">
             <a:avLst/>
@@ -22964,6 +22964,23 @@
                 <a:cs typeface="Segoe UI" pitchFamily="34" charset="-120"/>
               </a:rPr>
               <a:t>• Public network access: Disabled</a:t>
+            </a:r>
+            <a:endParaRPr lang="en-US" sz="1100" dirty="0"/>
+          </a:p>
+          <a:p>
+            <a:pPr indent="0" marL="0">
+              <a:buNone/>
+            </a:pPr>
+            <a:r>
+              <a:rPr lang="en-US" sz="900" dirty="0">
+                <a:solidFill>
+                  <a:srgbClr val="17255A"/>
+                </a:solidFill>
+                <a:latin typeface="Segoe UI" pitchFamily="34" charset="0"/>
+                <a:ea typeface="Segoe UI" pitchFamily="34" charset="-122"/>
+                <a:cs typeface="Segoe UI" pitchFamily="34" charset="-120"/>
+              </a:rPr>
+              <a:t>• Allow Azure services: Enabled (for Container App)</a:t>
             </a:r>
             <a:endParaRPr lang="en-US" sz="1100" dirty="0"/>
           </a:p>
@@ -23217,11 +23234,11 @@
         <p:spPr>
           <a:xfrm>
             <a:off x="548640" y="4389120"/>
-            <a:ext cx="3474720" cy="1389888"/>
+            <a:ext cx="3474720" cy="1591056"/>
           </a:xfrm>
           <a:prstGeom prst="rect">
             <a:avLst>
-              <a:gd name="adj" fmla="val 3947"/>
+              <a:gd name="adj" fmla="val 3448"/>
             </a:avLst>
           </a:prstGeom>
           <a:solidFill>
@@ -23264,7 +23281,7 @@
         <p:spPr>
           <a:xfrm>
             <a:off x="658368" y="4480560"/>
-            <a:ext cx="3255264" cy="1207008"/>
+            <a:ext cx="3255264" cy="1408176"/>
           </a:xfrm>
           <a:prstGeom prst="rect">
             <a:avLst/>
@@ -23288,7 +23305,7 @@
                 <a:ea typeface="Segoe UI" pitchFamily="34" charset="-122"/>
                 <a:cs typeface="Segoe UI" pitchFamily="34" charset="-120"/>
               </a:rPr>
-              <a:t>Ingress &amp; TLS</a:t>
+              <a:t>Ingress, TLS &amp; NSG Rules</a:t>
             </a:r>
             <a:endParaRPr lang="en-US" sz="1100" dirty="0"/>
           </a:p>
@@ -23339,24 +23356,41 @@
                 <a:ea typeface="Segoe UI" pitchFamily="34" charset="-122"/>
                 <a:cs typeface="Segoe UI" pitchFamily="34" charset="-120"/>
               </a:rPr>
+              <a:t>• NSG: Allow 443 inbound, deny all other inbound</a:t>
+            </a:r>
+            <a:endParaRPr lang="en-US" sz="1100" dirty="0"/>
+          </a:p>
+          <a:p>
+            <a:pPr indent="0" marL="0">
+              <a:buNone/>
+            </a:pPr>
+            <a:r>
+              <a:rPr lang="en-US" sz="900" dirty="0">
+                <a:solidFill>
+                  <a:srgbClr val="17255A"/>
+                </a:solidFill>
+                <a:latin typeface="Segoe UI" pitchFamily="34" charset="0"/>
+                <a:ea typeface="Segoe UI" pitchFamily="34" charset="-122"/>
+                <a:cs typeface="Segoe UI" pitchFamily="34" charset="-120"/>
+              </a:rPr>
+              <a:t>• NSG: Allow outbound to PG (5432), KV (443), Blob (443)</a:t>
+            </a:r>
+            <a:endParaRPr lang="en-US" sz="1100" dirty="0"/>
+          </a:p>
+          <a:p>
+            <a:pPr indent="0" marL="0">
+              <a:buNone/>
+            </a:pPr>
+            <a:r>
+              <a:rPr lang="en-US" sz="900" dirty="0">
+                <a:solidFill>
+                  <a:srgbClr val="17255A"/>
+                </a:solidFill>
+                <a:latin typeface="Segoe UI" pitchFamily="34" charset="0"/>
+                <a:ea typeface="Segoe UI" pitchFamily="34" charset="-122"/>
+                <a:cs typeface="Segoe UI" pitchFamily="34" charset="-120"/>
+              </a:rPr>
               <a:t>• Managed TLS certificate (auto-renewed)</a:t>
-            </a:r>
-            <a:endParaRPr lang="en-US" sz="1100" dirty="0"/>
-          </a:p>
-          <a:p>
-            <a:pPr indent="0" marL="0">
-              <a:buNone/>
-            </a:pPr>
-            <a:r>
-              <a:rPr lang="en-US" sz="900" dirty="0">
-                <a:solidFill>
-                  <a:srgbClr val="17255A"/>
-                </a:solidFill>
-                <a:latin typeface="Segoe UI" pitchFamily="34" charset="0"/>
-                <a:ea typeface="Segoe UI" pitchFamily="34" charset="-122"/>
-                <a:cs typeface="Segoe UI" pitchFamily="34" charset="-120"/>
-              </a:rPr>
-              <a:t>• CORS: Configured via Express middleware</a:t>
             </a:r>
             <a:endParaRPr lang="en-US" sz="1100" dirty="0"/>
           </a:p>

</xml_diff>